<commit_message>
Fix 12s dry-run & 30s retest motor logic, hardware connection banner on page load, responsive CSS, and PPT slide 1 update
</commit_message>
<xml_diff>
--- a/AquaMonitor_Presentation_Final_v3.pptx
+++ b/AquaMonitor_Presentation_Final_v3.pptx
@@ -3660,9 +3660,12 @@
           <a:prstGeom prst="roundRect">
             <a:avLst/>
           </a:prstGeom>
-          <a:solidFill>
-            <a:srgbClr val="FFFFFF"/>
-          </a:solidFill>
+          <a:blipFill>
+            <a:blip r:embed="rId3"/>
+            <a:stretch>
+              <a:fillRect/>
+            </a:stretch>
+          </a:blipFill>
           <a:ln w="19050">
             <a:solidFill>
               <a:srgbClr val="0EA5E9"/>
@@ -3686,25 +3689,7 @@
         <p:txBody>
           <a:bodyPr rtlCol="0" anchor="ctr" wrap="square" lIns="182880" rIns="182880" tIns="182880" bIns="182880"/>
           <a:lstStyle/>
-          <a:p>
-            <a:pPr algn="ctr">
-              <a:defRPr sz="1400" i="1">
-                <a:solidFill>
-                  <a:srgbClr val="475569"/>
-                </a:solidFill>
-                <a:latin typeface="Segoe UI"/>
-              </a:defRPr>
-            </a:pPr>
-            <a:br/>
-            <a:r>
-              <a:t>[ INSERT SYSTEM VISUAL HERE ]</a:t>
-            </a:r>
-            <a:br/>
-            <a:br/>
-            <a:r>
-              <a:t>Click to add your circuit image, hardware mockup, or UI dashboard screenshot.</a:t>
-            </a:r>
-          </a:p>
+          <a:p/>
         </p:txBody>
       </p:sp>
       <p:pic>

</xml_diff>

<commit_message>
Fix backend in-memory database caching, HTTP timeouts, and real-time telemetry dashboard sync
</commit_message>
<xml_diff>
--- a/AquaMonitor_Presentation_Final_v3.pptx
+++ b/AquaMonitor_Presentation_Final_v3.pptx
@@ -6558,67 +6558,6 @@
       </p:sp>
       <p:sp>
         <p:nvSpPr>
-          <p:cNvPr id="7" name="Rounded Rectangle 6"/>
-          <p:cNvSpPr/>
-          <p:nvPr/>
-        </p:nvSpPr>
-        <p:spPr>
-          <a:xfrm>
-            <a:off x="6217920" y="1645920"/>
-            <a:ext cx="5212080" cy="3291840"/>
-          </a:xfrm>
-          <a:prstGeom prst="roundRect">
-            <a:avLst/>
-          </a:prstGeom>
-          <a:solidFill>
-            <a:srgbClr val="FFFFFF"/>
-          </a:solidFill>
-          <a:ln w="19050">
-            <a:solidFill>
-              <a:srgbClr val="E2E8F0"/>
-            </a:solidFill>
-          </a:ln>
-        </p:spPr>
-        <p:style>
-          <a:lnRef idx="1">
-            <a:schemeClr val="accent1"/>
-          </a:lnRef>
-          <a:fillRef idx="3">
-            <a:schemeClr val="accent1"/>
-          </a:fillRef>
-          <a:effectRef idx="2">
-            <a:schemeClr val="accent1"/>
-          </a:effectRef>
-          <a:fontRef idx="minor">
-            <a:schemeClr val="lt1"/>
-          </a:fontRef>
-        </p:style>
-        <p:txBody>
-          <a:bodyPr rtlCol="0" anchor="ctr" wrap="square" lIns="182880" rIns="182880" tIns="182880" bIns="182880"/>
-          <a:lstStyle/>
-          <a:p>
-            <a:pPr algn="ctr">
-              <a:defRPr sz="1400" i="1">
-                <a:solidFill>
-                  <a:srgbClr val="475569"/>
-                </a:solidFill>
-                <a:latin typeface="Segoe UI"/>
-              </a:defRPr>
-            </a:pPr>
-            <a:br/>
-            <a:r>
-              <a:t>[ INSERT CIRCUIT DIAGRAM / SCHEMATIC HERE ]</a:t>
-            </a:r>
-            <a:br/>
-            <a:br/>
-            <a:r>
-              <a:t>Click to add your circuit wiring schematic or system block diagram.</a:t>
-            </a:r>
-          </a:p>
-        </p:txBody>
-      </p:sp>
-      <p:sp>
-        <p:nvSpPr>
           <p:cNvPr id="8" name="TextBox 7"/>
           <p:cNvSpPr txBox="1"/>
           <p:nvPr/>
@@ -6639,20 +6578,41 @@
           </a:bodyPr>
           <a:lstStyle/>
           <a:p>
-            <a:pPr algn="ctr">
-              <a:defRPr sz="1400" i="1">
-                <a:solidFill>
-                  <a:srgbClr val="475569"/>
-                </a:solidFill>
-                <a:latin typeface="Segoe UI"/>
-              </a:defRPr>
-            </a:pPr>
-            <a:r>
-              <a:t>Figure: Microcontroller-sensor integration loop showing active ultrasonic echo ranging and automatic wireless telemetry sync.</a:t>
-            </a:r>
-          </a:p>
-        </p:txBody>
-      </p:sp>
+            <a:pPr>
+              <a:defRPr sz="1100" i="1">
+                <a:latin typeface="Inter"/>
+              </a:defRPr>
+            </a:pPr>
+            <a:r>
+              <a:t>Figure: Operational flow logic &amp; automated pump relay trigger loop (3s interval).</a:t>
+            </a:r>
+          </a:p>
+        </p:txBody>
+      </p:sp>
+      <p:pic>
+        <p:nvPicPr>
+          <p:cNvPr id="9" name="Picture 8" descr="flowchart_slide5.png"/>
+          <p:cNvPicPr>
+            <a:picLocks noChangeAspect="1"/>
+          </p:cNvPicPr>
+          <p:nvPr/>
+        </p:nvPicPr>
+        <p:blipFill>
+          <a:blip r:embed="rId2"/>
+          <a:stretch>
+            <a:fillRect/>
+          </a:stretch>
+        </p:blipFill>
+        <p:spPr>
+          <a:xfrm>
+            <a:off x="6217920" y="1645920"/>
+            <a:ext cx="5212080" cy="3291840"/>
+          </a:xfrm>
+          <a:prstGeom prst="rect">
+            <a:avLst/>
+          </a:prstGeom>
+        </p:spPr>
+      </p:pic>
     </p:spTree>
   </p:cSld>
   <p:clrMapOvr>

</xml_diff>